<commit_message>
Split national projects slide goals into 2030 and 2036 columns
Co-Authored-By: Claude Sonnet 5.5 <noreply@anthropic.com>
Claude-Session: https://claude.ai/code/session_01PfagTkBBfn3ShTm5bX9M45
</commit_message>
<xml_diff>
--- a/slide_natsproekty.pptx
+++ b/slide_natsproekty.pptx
@@ -430,7 +430,7 @@
           <a:lstStyle/>
           <a:p>
             <a:r>
-              <a:t>Цифры по нацпроектам взяты из открытых описаний (government.ru, национальныепроекты.рф, профильные СМИ) и требуют сверки с паспортами нацпроектов. Особенно: 103,4% и 360 профессий («Кадры»); 100% сортировки ТКО и «вдвое меньше стоков к 2036» («Экологическое благополучие»); 140 млн поездок и 5% ВВП («Туризм»); +15% многодетных семей («Семья»); срок цели по жилью 33 м² (источники расходятся: 2030 или 2036). Строки «как встраивается село» — трактовка автора: в нацпроектах отдельных сельских целей не найдено.</a:t>
+              <a:t>Цифры по нацпроектам взяты из открытых описаний (government.ru, национальныепроекты.рф, профильные СМИ) и требуют сверки с паспортами нацпроектов. Особенно: 103,4% («Кадры»); 100% сортировки ТКО и «вдвое меньше стоков к 2036» («Экологическое благополучие»); 140 млн поездок и 5% ВВП («Туризм»); +15% многодетных семей («Семья»); 33 м² жилья на человека (источники расходятся: к 2030 или к 2036 году; значение на 2036 год не указано). Прочерк в колонке 2036 — целевое значение на этот год в найденных источниках не обнаружено, это не значит, что цели нет. Колонка «Как встраивается село» — трактовка автора: в нацпроектах отдельных сельских целей не найдено.</a:t>
             </a:r>
           </a:p>
         </p:txBody>
@@ -6308,8 +6308,8 @@
         </p:nvSpPr>
         <p:spPr>
           <a:xfrm>
-            <a:off x="1069330" y="9281160"/>
-            <a:ext cx="16871653" cy="320040"/>
+            <a:off x="1069330" y="9235440"/>
+            <a:ext cx="16871653" cy="548640"/>
           </a:xfrm>
           <a:prstGeom prst="rect">
             <a:avLst/>
@@ -6331,7 +6331,7 @@
                 </a:solidFill>
                 <a:latin typeface="Circe"/>
               </a:rPr>
-              <a:t>Источники: Указ Президента РФ от 07.05.2024 № 309; описания и паспорта национальных проектов (government.ru, национальныепроекты.рф); Минсельхоз России</a:t>
+              <a:t>Источники: Указ Президента РФ от 07.05.2024 № 309; описания и паспорта национальных проектов (government.ru, национальныепроекты.рф); Минсельхоз России. «—»: целевое значение на 2036 г. в открытых источниках не найдено</a:t>
             </a:r>
           </a:p>
         </p:txBody>
@@ -6371,7 +6371,7 @@
                 </a:solidFill>
                 <a:latin typeface="Circe Bold"/>
               </a:rPr>
-              <a:t>НАЦИОНАЛЬНЫЙ ПРОЕКТ</a:t>
+              <a:t>НАЦПРОЕКТ</a:t>
             </a:r>
           </a:p>
         </p:txBody>
@@ -6384,8 +6384,8 @@
         </p:nvSpPr>
         <p:spPr>
           <a:xfrm>
-            <a:off x="5413248" y="2103120"/>
-            <a:ext cx="6583680" cy="566928"/>
+            <a:off x="5385816" y="2103120"/>
+            <a:ext cx="4297680" cy="566928"/>
           </a:xfrm>
           <a:prstGeom prst="roundRect">
             <a:avLst>
@@ -6411,7 +6411,7 @@
                 </a:solidFill>
                 <a:latin typeface="Circe Bold"/>
               </a:rPr>
-              <a:t>КОНКРЕТНЫЕ ЦЕЛИ</a:t>
+              <a:t>ЦЕЛИ К 2030 Г.</a:t>
             </a:r>
           </a:p>
         </p:txBody>
@@ -6424,8 +6424,8 @@
         </p:nvSpPr>
         <p:spPr>
           <a:xfrm>
-            <a:off x="12134088" y="2103120"/>
-            <a:ext cx="5806440" cy="566928"/>
+            <a:off x="9793224" y="2103120"/>
+            <a:ext cx="2926080" cy="566928"/>
           </a:xfrm>
           <a:prstGeom prst="roundRect">
             <a:avLst>
@@ -6451,14 +6451,54 @@
                 </a:solidFill>
                 <a:latin typeface="Circe Bold"/>
               </a:rPr>
-              <a:t>КАК ВСТРАИВАЕТСЯ СЕЛО</a:t>
+              <a:t>ЦЕЛИ К 2036 Г.</a:t>
             </a:r>
           </a:p>
         </p:txBody>
       </p:sp>
       <p:sp>
         <p:nvSpPr>
-          <p:cNvPr id="207" name="Нацпроект"/>
+          <p:cNvPr id="207" name="Заголовок колонки"/>
+          <p:cNvSpPr/>
+          <p:nvPr/>
+        </p:nvSpPr>
+        <p:spPr>
+          <a:xfrm>
+            <a:off x="12829032" y="2103120"/>
+            <a:ext cx="5111495" cy="566928"/>
+          </a:xfrm>
+          <a:prstGeom prst="roundRect">
+            <a:avLst>
+              <a:gd name="adj" fmla="val 12000"/>
+            </a:avLst>
+          </a:prstGeom>
+          <a:solidFill>
+            <a:srgbClr val="FFCC00"/>
+          </a:solidFill>
+          <a:ln>
+            <a:noFill/>
+          </a:ln>
+        </p:spPr>
+        <p:txBody>
+          <a:bodyPr rtlCol="0" anchor="ctr" wrap="square" lIns="182880" rIns="182880" tIns="0" bIns="0"/>
+          <a:lstStyle/>
+          <a:p>
+            <a:pPr algn="ctr"/>
+            <a:r>
+              <a:rPr sz="2100" b="1">
+                <a:solidFill>
+                  <a:srgbClr val="062D3F"/>
+                </a:solidFill>
+                <a:latin typeface="Circe Bold"/>
+              </a:rPr>
+              <a:t>КАК ВСТРАИВАЕТСЯ СЕЛО</a:t>
+            </a:r>
+          </a:p>
+        </p:txBody>
+      </p:sp>
+      <p:sp>
+        <p:nvSpPr>
+          <p:cNvPr id="208" name="Нацпроект"/>
           <p:cNvSpPr/>
           <p:nvPr/>
         </p:nvSpPr>
@@ -6498,14 +6538,14 @@
       </p:sp>
       <p:sp>
         <p:nvSpPr>
-          <p:cNvPr id="208" name="Цели"/>
+          <p:cNvPr id="209" name="Цели 2030"/>
           <p:cNvSpPr/>
           <p:nvPr/>
         </p:nvSpPr>
         <p:spPr>
           <a:xfrm>
-            <a:off x="5413248" y="2788920"/>
-            <a:ext cx="6583680" cy="841248"/>
+            <a:off x="5385816" y="2788920"/>
+            <a:ext cx="4297680" cy="841248"/>
           </a:xfrm>
           <a:prstGeom prst="roundRect">
             <a:avLst>
@@ -6525,7 +6565,7 @@
           <a:p>
             <a:pPr algn="l"/>
             <a:r>
-              <a:rPr sz="1800" b="0">
+              <a:rPr sz="1700" b="0">
                 <a:solidFill>
                   <a:srgbClr val="062D3F"/>
                 </a:solidFill>
@@ -6534,34 +6574,16 @@
               <a:t>Качество среды в опорных пунктах </a:t>
             </a:r>
             <a:r>
-              <a:rPr sz="1800" b="1">
+              <a:rPr sz="1700" b="1">
                 <a:solidFill>
                   <a:srgbClr val="062D3F"/>
                 </a:solidFill>
                 <a:latin typeface="Circe Bold"/>
               </a:rPr>
-              <a:t>+30% к 2030</a:t>
+              <a:t>+30%</a:t>
             </a:r>
             <a:r>
-              <a:rPr sz="1800" b="0">
-                <a:solidFill>
-                  <a:srgbClr val="062D3F"/>
-                </a:solidFill>
-                <a:latin typeface="Circe"/>
-              </a:rPr>
-              <a:t> и </a:t>
-            </a:r>
-            <a:r>
-              <a:rPr sz="1800" b="1">
-                <a:solidFill>
-                  <a:srgbClr val="062D3F"/>
-                </a:solidFill>
-                <a:latin typeface="Circe Bold"/>
-              </a:rPr>
-              <a:t>+60% к 2036</a:t>
-            </a:r>
-            <a:r>
-              <a:rPr sz="1800" b="0">
+              <a:rPr sz="1700" b="0">
                 <a:solidFill>
                   <a:srgbClr val="062D3F"/>
                 </a:solidFill>
@@ -6570,7 +6592,7 @@
               <a:t>; жильё </a:t>
             </a:r>
             <a:r>
-              <a:rPr sz="1800" b="1">
+              <a:rPr sz="1700" b="1">
                 <a:solidFill>
                   <a:srgbClr val="062D3F"/>
                 </a:solidFill>
@@ -6579,7 +6601,7 @@
               <a:t>33 м²</a:t>
             </a:r>
             <a:r>
-              <a:rPr sz="1800" b="0">
+              <a:rPr sz="1700" b="0">
                 <a:solidFill>
                   <a:srgbClr val="062D3F"/>
                 </a:solidFill>
@@ -6592,14 +6614,63 @@
       </p:sp>
       <p:sp>
         <p:nvSpPr>
-          <p:cNvPr id="209" name="Роль села"/>
+          <p:cNvPr id="210" name="Цели 2036"/>
           <p:cNvSpPr/>
           <p:nvPr/>
         </p:nvSpPr>
         <p:spPr>
           <a:xfrm>
-            <a:off x="12134088" y="2788920"/>
-            <a:ext cx="5806440" cy="841248"/>
+            <a:off x="9793224" y="2788920"/>
+            <a:ext cx="2926080" cy="841248"/>
+          </a:xfrm>
+          <a:prstGeom prst="roundRect">
+            <a:avLst>
+              <a:gd name="adj" fmla="val 12000"/>
+            </a:avLst>
+          </a:prstGeom>
+          <a:solidFill>
+            <a:srgbClr val="FFF3CC"/>
+          </a:solidFill>
+          <a:ln>
+            <a:noFill/>
+          </a:ln>
+        </p:spPr>
+        <p:txBody>
+          <a:bodyPr rtlCol="0" anchor="ctr" wrap="square" lIns="182880" rIns="182880" tIns="0" bIns="0"/>
+          <a:lstStyle/>
+          <a:p>
+            <a:pPr algn="l"/>
+            <a:r>
+              <a:rPr sz="1700" b="0">
+                <a:solidFill>
+                  <a:srgbClr val="062D3F"/>
+                </a:solidFill>
+                <a:latin typeface="Circe"/>
+              </a:rPr>
+              <a:t>Качество среды </a:t>
+            </a:r>
+            <a:r>
+              <a:rPr sz="1700" b="1">
+                <a:solidFill>
+                  <a:srgbClr val="062D3F"/>
+                </a:solidFill>
+                <a:latin typeface="Circe Bold"/>
+              </a:rPr>
+              <a:t>+60%</a:t>
+            </a:r>
+          </a:p>
+        </p:txBody>
+      </p:sp>
+      <p:sp>
+        <p:nvSpPr>
+          <p:cNvPr id="211" name="Роль села"/>
+          <p:cNvSpPr/>
+          <p:nvPr/>
+        </p:nvSpPr>
+        <p:spPr>
+          <a:xfrm>
+            <a:off x="12829032" y="2788920"/>
+            <a:ext cx="5111495" cy="841248"/>
           </a:xfrm>
           <a:prstGeom prst="roundRect">
             <a:avLst>
@@ -6619,7 +6690,7 @@
           <a:p>
             <a:pPr algn="l"/>
             <a:r>
-              <a:rPr sz="1800" b="0">
+              <a:rPr sz="1700" b="0">
                 <a:solidFill>
                   <a:srgbClr val="062D3F"/>
                 </a:solidFill>
@@ -6632,7 +6703,7 @@
       </p:sp>
       <p:sp>
         <p:nvSpPr>
-          <p:cNvPr id="210" name="Нацпроект"/>
+          <p:cNvPr id="212" name="Нацпроект"/>
           <p:cNvSpPr/>
           <p:nvPr/>
         </p:nvSpPr>
@@ -6672,14 +6743,14 @@
       </p:sp>
       <p:sp>
         <p:nvSpPr>
-          <p:cNvPr id="211" name="Цели"/>
+          <p:cNvPr id="213" name="Цели 2030"/>
           <p:cNvSpPr/>
           <p:nvPr/>
         </p:nvSpPr>
         <p:spPr>
           <a:xfrm>
-            <a:off x="5413248" y="3712463"/>
-            <a:ext cx="6583680" cy="841248"/>
+            <a:off x="5385816" y="3712463"/>
+            <a:ext cx="4297680" cy="841248"/>
           </a:xfrm>
           <a:prstGeom prst="roundRect">
             <a:avLst>
@@ -6699,7 +6770,7 @@
           <a:p>
             <a:pPr algn="l"/>
             <a:r>
-              <a:rPr sz="1800" b="0">
+              <a:rPr sz="1700" b="0">
                 <a:solidFill>
                   <a:srgbClr val="062D3F"/>
                 </a:solidFill>
@@ -6708,7 +6779,7 @@
               <a:t>Технологическая независимость </a:t>
             </a:r>
             <a:r>
-              <a:rPr sz="1800" b="1">
+              <a:rPr sz="1700" b="1">
                 <a:solidFill>
                   <a:srgbClr val="062D3F"/>
                 </a:solidFill>
@@ -6717,16 +6788,16 @@
               <a:t>66,7%</a:t>
             </a:r>
             <a:r>
-              <a:rPr sz="1800" b="0">
+              <a:rPr sz="1700" b="0">
                 <a:solidFill>
                   <a:srgbClr val="062D3F"/>
                 </a:solidFill>
                 <a:latin typeface="Circe"/>
               </a:rPr>
-              <a:t> к 2030 (55,8% в 2025); семена отечественной селекции </a:t>
+              <a:t> (55,8% в 2025); семена отечественной селекции </a:t>
             </a:r>
             <a:r>
-              <a:rPr sz="1800" b="1">
+              <a:rPr sz="1700" b="1">
                 <a:solidFill>
                   <a:srgbClr val="062D3F"/>
                 </a:solidFill>
@@ -6739,14 +6810,54 @@
       </p:sp>
       <p:sp>
         <p:nvSpPr>
-          <p:cNvPr id="212" name="Роль села"/>
+          <p:cNvPr id="214" name="Цели 2036"/>
           <p:cNvSpPr/>
           <p:nvPr/>
         </p:nvSpPr>
         <p:spPr>
           <a:xfrm>
-            <a:off x="12134088" y="3712463"/>
-            <a:ext cx="5806440" cy="841248"/>
+            <a:off x="9793224" y="3712463"/>
+            <a:ext cx="2926080" cy="841248"/>
+          </a:xfrm>
+          <a:prstGeom prst="roundRect">
+            <a:avLst>
+              <a:gd name="adj" fmla="val 12000"/>
+            </a:avLst>
+          </a:prstGeom>
+          <a:solidFill>
+            <a:srgbClr val="FFF3CC"/>
+          </a:solidFill>
+          <a:ln>
+            <a:noFill/>
+          </a:ln>
+        </p:spPr>
+        <p:txBody>
+          <a:bodyPr rtlCol="0" anchor="ctr" wrap="square" lIns="182880" rIns="182880" tIns="0" bIns="0"/>
+          <a:lstStyle/>
+          <a:p>
+            <a:pPr algn="ctr"/>
+            <a:r>
+              <a:rPr sz="1700" b="0">
+                <a:solidFill>
+                  <a:srgbClr val="5E6B73"/>
+                </a:solidFill>
+                <a:latin typeface="Circe"/>
+              </a:rPr>
+              <a:t>—</a:t>
+            </a:r>
+          </a:p>
+        </p:txBody>
+      </p:sp>
+      <p:sp>
+        <p:nvSpPr>
+          <p:cNvPr id="215" name="Роль села"/>
+          <p:cNvSpPr/>
+          <p:nvPr/>
+        </p:nvSpPr>
+        <p:spPr>
+          <a:xfrm>
+            <a:off x="12829032" y="3712463"/>
+            <a:ext cx="5111495" cy="841248"/>
           </a:xfrm>
           <a:prstGeom prst="roundRect">
             <a:avLst>
@@ -6766,7 +6877,7 @@
           <a:p>
             <a:pPr algn="l"/>
             <a:r>
-              <a:rPr sz="1800" b="0">
+              <a:rPr sz="1700" b="0">
                 <a:solidFill>
                   <a:srgbClr val="062D3F"/>
                 </a:solidFill>
@@ -6779,7 +6890,7 @@
       </p:sp>
       <p:sp>
         <p:nvSpPr>
-          <p:cNvPr id="213" name="Нацпроект"/>
+          <p:cNvPr id="216" name="Нацпроект"/>
           <p:cNvSpPr/>
           <p:nvPr/>
         </p:nvSpPr>
@@ -6819,14 +6930,14 @@
       </p:sp>
       <p:sp>
         <p:nvSpPr>
-          <p:cNvPr id="214" name="Цели"/>
+          <p:cNvPr id="217" name="Цели 2030"/>
           <p:cNvSpPr/>
           <p:nvPr/>
         </p:nvSpPr>
         <p:spPr>
           <a:xfrm>
-            <a:off x="5413248" y="4636008"/>
-            <a:ext cx="6583680" cy="841248"/>
+            <a:off x="5385816" y="4636008"/>
+            <a:ext cx="4297680" cy="841248"/>
           </a:xfrm>
           <a:prstGeom prst="roundRect">
             <a:avLst>
@@ -6846,7 +6957,7 @@
           <a:p>
             <a:pPr algn="l"/>
             <a:r>
-              <a:rPr sz="1800" b="0">
+              <a:rPr sz="1700" b="0">
                 <a:solidFill>
                   <a:srgbClr val="062D3F"/>
                 </a:solidFill>
@@ -6855,7 +6966,7 @@
               <a:t>Суммарный коэффициент рождаемости </a:t>
             </a:r>
             <a:r>
-              <a:rPr sz="1800" b="1">
+              <a:rPr sz="1700" b="1">
                 <a:solidFill>
                   <a:srgbClr val="062D3F"/>
                 </a:solidFill>
@@ -6864,16 +6975,65 @@
               <a:t>1,6</a:t>
             </a:r>
             <a:r>
-              <a:rPr sz="1800" b="0">
+              <a:rPr sz="1700" b="0">
                 <a:solidFill>
                   <a:srgbClr val="062D3F"/>
                 </a:solidFill>
                 <a:latin typeface="Circe"/>
               </a:rPr>
-              <a:t> к 2030 и </a:t>
+              <a:t>; многодетных семей </a:t>
             </a:r>
             <a:r>
-              <a:rPr sz="1800" b="1">
+              <a:rPr sz="1700" b="1">
+                <a:solidFill>
+                  <a:srgbClr val="062D3F"/>
+                </a:solidFill>
+                <a:latin typeface="Circe Bold"/>
+              </a:rPr>
+              <a:t>+15%</a:t>
+            </a:r>
+          </a:p>
+        </p:txBody>
+      </p:sp>
+      <p:sp>
+        <p:nvSpPr>
+          <p:cNvPr id="218" name="Цели 2036"/>
+          <p:cNvSpPr/>
+          <p:nvPr/>
+        </p:nvSpPr>
+        <p:spPr>
+          <a:xfrm>
+            <a:off x="9793224" y="4636008"/>
+            <a:ext cx="2926080" cy="841248"/>
+          </a:xfrm>
+          <a:prstGeom prst="roundRect">
+            <a:avLst>
+              <a:gd name="adj" fmla="val 12000"/>
+            </a:avLst>
+          </a:prstGeom>
+          <a:solidFill>
+            <a:srgbClr val="FFF3CC"/>
+          </a:solidFill>
+          <a:ln>
+            <a:noFill/>
+          </a:ln>
+        </p:spPr>
+        <p:txBody>
+          <a:bodyPr rtlCol="0" anchor="ctr" wrap="square" lIns="182880" rIns="182880" tIns="0" bIns="0"/>
+          <a:lstStyle/>
+          <a:p>
+            <a:pPr algn="l"/>
+            <a:r>
+              <a:rPr sz="1700" b="0">
+                <a:solidFill>
+                  <a:srgbClr val="062D3F"/>
+                </a:solidFill>
+                <a:latin typeface="Circe"/>
+              </a:rPr>
+              <a:t>Суммарный коэффициент рождаемости </a:t>
+            </a:r>
+            <a:r>
+              <a:rPr sz="1700" b="1">
                 <a:solidFill>
                   <a:srgbClr val="062D3F"/>
                 </a:solidFill>
@@ -6881,46 +7041,19 @@
               </a:rPr>
               <a:t>1,8</a:t>
             </a:r>
-            <a:r>
-              <a:rPr sz="1800" b="0">
-                <a:solidFill>
-                  <a:srgbClr val="062D3F"/>
-                </a:solidFill>
-                <a:latin typeface="Circe"/>
-              </a:rPr>
-              <a:t> к 2036; многодетных семей </a:t>
-            </a:r>
-            <a:r>
-              <a:rPr sz="1800" b="1">
-                <a:solidFill>
-                  <a:srgbClr val="062D3F"/>
-                </a:solidFill>
-                <a:latin typeface="Circe Bold"/>
-              </a:rPr>
-              <a:t>+15%</a:t>
-            </a:r>
-            <a:r>
-              <a:rPr sz="1800" b="0">
-                <a:solidFill>
-                  <a:srgbClr val="062D3F"/>
-                </a:solidFill>
-                <a:latin typeface="Circe"/>
-              </a:rPr>
-              <a:t> к 2030</a:t>
-            </a:r>
           </a:p>
         </p:txBody>
       </p:sp>
       <p:sp>
         <p:nvSpPr>
-          <p:cNvPr id="215" name="Роль села"/>
+          <p:cNvPr id="219" name="Роль села"/>
           <p:cNvSpPr/>
           <p:nvPr/>
         </p:nvSpPr>
         <p:spPr>
           <a:xfrm>
-            <a:off x="12134088" y="4636008"/>
-            <a:ext cx="5806440" cy="841248"/>
+            <a:off x="12829032" y="4636008"/>
+            <a:ext cx="5111495" cy="841248"/>
           </a:xfrm>
           <a:prstGeom prst="roundRect">
             <a:avLst>
@@ -6940,7 +7073,7 @@
           <a:p>
             <a:pPr algn="l"/>
             <a:r>
-              <a:rPr sz="1800" b="0">
+              <a:rPr sz="1700" b="0">
                 <a:solidFill>
                   <a:srgbClr val="062D3F"/>
                 </a:solidFill>
@@ -6953,7 +7086,7 @@
       </p:sp>
       <p:sp>
         <p:nvSpPr>
-          <p:cNvPr id="216" name="Нацпроект"/>
+          <p:cNvPr id="220" name="Нацпроект"/>
           <p:cNvSpPr/>
           <p:nvPr/>
         </p:nvSpPr>
@@ -6993,14 +7126,14 @@
       </p:sp>
       <p:sp>
         <p:nvSpPr>
-          <p:cNvPr id="217" name="Цели"/>
+          <p:cNvPr id="221" name="Цели 2030"/>
           <p:cNvSpPr/>
           <p:nvPr/>
         </p:nvSpPr>
         <p:spPr>
           <a:xfrm>
-            <a:off x="5413248" y="5559552"/>
-            <a:ext cx="6583680" cy="841248"/>
+            <a:off x="5385816" y="5559552"/>
+            <a:ext cx="4297680" cy="841248"/>
           </a:xfrm>
           <a:prstGeom prst="roundRect">
             <a:avLst>
@@ -7020,16 +7153,16 @@
           <a:p>
             <a:pPr algn="l"/>
             <a:r>
-              <a:rPr sz="1800" b="0">
+              <a:rPr sz="1700" b="0">
                 <a:solidFill>
                   <a:srgbClr val="062D3F"/>
                 </a:solidFill>
                 <a:latin typeface="Circe"/>
               </a:rPr>
-              <a:t>Сокращение дефицита кадров: темп </a:t>
+              <a:t>Темп сокращения дефицита кадров </a:t>
             </a:r>
             <a:r>
-              <a:rPr sz="1800" b="1">
+              <a:rPr sz="1700" b="1">
                 <a:solidFill>
                   <a:srgbClr val="062D3F"/>
                 </a:solidFill>
@@ -7038,45 +7171,67 @@
               <a:t>103,4%</a:t>
             </a:r>
             <a:r>
-              <a:rPr sz="1800" b="0">
+              <a:rPr sz="1700" b="0">
                 <a:solidFill>
                   <a:srgbClr val="062D3F"/>
                 </a:solidFill>
                 <a:latin typeface="Circe"/>
               </a:rPr>
-              <a:t> к 2022 г.; бесплатное обучение по </a:t>
-            </a:r>
-            <a:r>
-              <a:rPr sz="1800" b="1">
-                <a:solidFill>
-                  <a:srgbClr val="062D3F"/>
-                </a:solidFill>
-                <a:latin typeface="Circe Bold"/>
-              </a:rPr>
-              <a:t>360</a:t>
-            </a:r>
-            <a:r>
-              <a:rPr sz="1800" b="0">
-                <a:solidFill>
-                  <a:srgbClr val="062D3F"/>
-                </a:solidFill>
-                <a:latin typeface="Circe"/>
-              </a:rPr>
-              <a:t> профессиям</a:t>
+              <a:t> к 2022 г.</a:t>
             </a:r>
           </a:p>
         </p:txBody>
       </p:sp>
       <p:sp>
         <p:nvSpPr>
-          <p:cNvPr id="218" name="Роль села"/>
+          <p:cNvPr id="222" name="Цели 2036"/>
           <p:cNvSpPr/>
           <p:nvPr/>
         </p:nvSpPr>
         <p:spPr>
           <a:xfrm>
-            <a:off x="12134088" y="5559552"/>
-            <a:ext cx="5806440" cy="841248"/>
+            <a:off x="9793224" y="5559552"/>
+            <a:ext cx="2926080" cy="841248"/>
+          </a:xfrm>
+          <a:prstGeom prst="roundRect">
+            <a:avLst>
+              <a:gd name="adj" fmla="val 12000"/>
+            </a:avLst>
+          </a:prstGeom>
+          <a:solidFill>
+            <a:srgbClr val="FFF3CC"/>
+          </a:solidFill>
+          <a:ln>
+            <a:noFill/>
+          </a:ln>
+        </p:spPr>
+        <p:txBody>
+          <a:bodyPr rtlCol="0" anchor="ctr" wrap="square" lIns="182880" rIns="182880" tIns="0" bIns="0"/>
+          <a:lstStyle/>
+          <a:p>
+            <a:pPr algn="ctr"/>
+            <a:r>
+              <a:rPr sz="1700" b="0">
+                <a:solidFill>
+                  <a:srgbClr val="5E6B73"/>
+                </a:solidFill>
+                <a:latin typeface="Circe"/>
+              </a:rPr>
+              <a:t>—</a:t>
+            </a:r>
+          </a:p>
+        </p:txBody>
+      </p:sp>
+      <p:sp>
+        <p:nvSpPr>
+          <p:cNvPr id="223" name="Роль села"/>
+          <p:cNvSpPr/>
+          <p:nvPr/>
+        </p:nvSpPr>
+        <p:spPr>
+          <a:xfrm>
+            <a:off x="12829032" y="5559552"/>
+            <a:ext cx="5111495" cy="841248"/>
           </a:xfrm>
           <a:prstGeom prst="roundRect">
             <a:avLst>
@@ -7096,7 +7251,7 @@
           <a:p>
             <a:pPr algn="l"/>
             <a:r>
-              <a:rPr sz="1800" b="0">
+              <a:rPr sz="1700" b="0">
                 <a:solidFill>
                   <a:srgbClr val="062D3F"/>
                 </a:solidFill>
@@ -7109,7 +7264,7 @@
       </p:sp>
       <p:sp>
         <p:nvSpPr>
-          <p:cNvPr id="219" name="Нацпроект"/>
+          <p:cNvPr id="224" name="Нацпроект"/>
           <p:cNvSpPr/>
           <p:nvPr/>
         </p:nvSpPr>
@@ -7149,14 +7304,14 @@
       </p:sp>
       <p:sp>
         <p:nvSpPr>
-          <p:cNvPr id="220" name="Цели"/>
+          <p:cNvPr id="225" name="Цели 2030"/>
           <p:cNvSpPr/>
           <p:nvPr/>
         </p:nvSpPr>
         <p:spPr>
           <a:xfrm>
-            <a:off x="5413248" y="6483096"/>
-            <a:ext cx="6583680" cy="841248"/>
+            <a:off x="5385816" y="6483096"/>
+            <a:ext cx="4297680" cy="841248"/>
           </a:xfrm>
           <a:prstGeom prst="roundRect">
             <a:avLst>
@@ -7176,16 +7331,7 @@
           <a:p>
             <a:pPr algn="l"/>
             <a:r>
-              <a:rPr sz="1800" b="0">
-                <a:solidFill>
-                  <a:srgbClr val="062D3F"/>
-                </a:solidFill>
-                <a:latin typeface="Circe"/>
-              </a:rPr>
-              <a:t>Турпоездки </a:t>
-            </a:r>
-            <a:r>
-              <a:rPr sz="1800" b="1">
+              <a:rPr sz="1700" b="1">
                 <a:solidFill>
                   <a:srgbClr val="062D3F"/>
                 </a:solidFill>
@@ -7194,16 +7340,16 @@
               <a:t>140 млн</a:t>
             </a:r>
             <a:r>
-              <a:rPr sz="1800" b="0">
+              <a:rPr sz="1700" b="0">
                 <a:solidFill>
                   <a:srgbClr val="062D3F"/>
                 </a:solidFill>
                 <a:latin typeface="Circe"/>
               </a:rPr>
-              <a:t> в год к 2030; доля туризма в ВВП </a:t>
+              <a:t> турпоездок в год; доля туризма в ВВП </a:t>
             </a:r>
             <a:r>
-              <a:rPr sz="1800" b="1">
+              <a:rPr sz="1700" b="1">
                 <a:solidFill>
                   <a:srgbClr val="062D3F"/>
                 </a:solidFill>
@@ -7216,14 +7362,54 @@
       </p:sp>
       <p:sp>
         <p:nvSpPr>
-          <p:cNvPr id="221" name="Роль села"/>
+          <p:cNvPr id="226" name="Цели 2036"/>
           <p:cNvSpPr/>
           <p:nvPr/>
         </p:nvSpPr>
         <p:spPr>
           <a:xfrm>
-            <a:off x="12134088" y="6483096"/>
-            <a:ext cx="5806440" cy="841248"/>
+            <a:off x="9793224" y="6483096"/>
+            <a:ext cx="2926080" cy="841248"/>
+          </a:xfrm>
+          <a:prstGeom prst="roundRect">
+            <a:avLst>
+              <a:gd name="adj" fmla="val 12000"/>
+            </a:avLst>
+          </a:prstGeom>
+          <a:solidFill>
+            <a:srgbClr val="FFF3CC"/>
+          </a:solidFill>
+          <a:ln>
+            <a:noFill/>
+          </a:ln>
+        </p:spPr>
+        <p:txBody>
+          <a:bodyPr rtlCol="0" anchor="ctr" wrap="square" lIns="182880" rIns="182880" tIns="0" bIns="0"/>
+          <a:lstStyle/>
+          <a:p>
+            <a:pPr algn="ctr"/>
+            <a:r>
+              <a:rPr sz="1700" b="0">
+                <a:solidFill>
+                  <a:srgbClr val="5E6B73"/>
+                </a:solidFill>
+                <a:latin typeface="Circe"/>
+              </a:rPr>
+              <a:t>—</a:t>
+            </a:r>
+          </a:p>
+        </p:txBody>
+      </p:sp>
+      <p:sp>
+        <p:nvSpPr>
+          <p:cNvPr id="227" name="Роль села"/>
+          <p:cNvSpPr/>
+          <p:nvPr/>
+        </p:nvSpPr>
+        <p:spPr>
+          <a:xfrm>
+            <a:off x="12829032" y="6483096"/>
+            <a:ext cx="5111495" cy="841248"/>
           </a:xfrm>
           <a:prstGeom prst="roundRect">
             <a:avLst>
@@ -7243,7 +7429,7 @@
           <a:p>
             <a:pPr algn="l"/>
             <a:r>
-              <a:rPr sz="1800" b="0">
+              <a:rPr sz="1700" b="0">
                 <a:solidFill>
                   <a:srgbClr val="062D3F"/>
                 </a:solidFill>
@@ -7256,7 +7442,7 @@
       </p:sp>
       <p:sp>
         <p:nvSpPr>
-          <p:cNvPr id="222" name="Нацпроект"/>
+          <p:cNvPr id="228" name="Нацпроект"/>
           <p:cNvSpPr/>
           <p:nvPr/>
         </p:nvSpPr>
@@ -7296,14 +7482,14 @@
       </p:sp>
       <p:sp>
         <p:nvSpPr>
-          <p:cNvPr id="223" name="Цели"/>
+          <p:cNvPr id="229" name="Цели 2030"/>
           <p:cNvSpPr/>
           <p:nvPr/>
         </p:nvSpPr>
         <p:spPr>
           <a:xfrm>
-            <a:off x="5413248" y="7406640"/>
-            <a:ext cx="6583680" cy="841248"/>
+            <a:off x="5385816" y="7406640"/>
+            <a:ext cx="4297680" cy="841248"/>
           </a:xfrm>
           <a:prstGeom prst="roundRect">
             <a:avLst>
@@ -7323,7 +7509,7 @@
           <a:p>
             <a:pPr algn="l"/>
             <a:r>
-              <a:rPr sz="1800" b="0">
+              <a:rPr sz="1700" b="0">
                 <a:solidFill>
                   <a:srgbClr val="062D3F"/>
                 </a:solidFill>
@@ -7332,7 +7518,7 @@
               <a:t>Сортировка </a:t>
             </a:r>
             <a:r>
-              <a:rPr sz="1800" b="1">
+              <a:rPr sz="1700" b="1">
                 <a:solidFill>
                   <a:srgbClr val="062D3F"/>
                 </a:solidFill>
@@ -7341,7 +7527,7 @@
               <a:t>100%</a:t>
             </a:r>
             <a:r>
-              <a:rPr sz="1800" b="0">
+              <a:rPr sz="1700" b="0">
                 <a:solidFill>
                   <a:srgbClr val="062D3F"/>
                 </a:solidFill>
@@ -7350,7 +7536,7 @@
               <a:t> ТКО, захоронение не более </a:t>
             </a:r>
             <a:r>
-              <a:rPr sz="1800" b="1">
+              <a:rPr sz="1700" b="1">
                 <a:solidFill>
                   <a:srgbClr val="062D3F"/>
                 </a:solidFill>
@@ -7358,28 +7544,59 @@
               </a:rPr>
               <a:t>50%</a:t>
             </a:r>
+          </a:p>
+        </p:txBody>
+      </p:sp>
+      <p:sp>
+        <p:nvSpPr>
+          <p:cNvPr id="230" name="Цели 2036"/>
+          <p:cNvSpPr/>
+          <p:nvPr/>
+        </p:nvSpPr>
+        <p:spPr>
+          <a:xfrm>
+            <a:off x="9793224" y="7406640"/>
+            <a:ext cx="2926080" cy="841248"/>
+          </a:xfrm>
+          <a:prstGeom prst="roundRect">
+            <a:avLst>
+              <a:gd name="adj" fmla="val 12000"/>
+            </a:avLst>
+          </a:prstGeom>
+          <a:solidFill>
+            <a:srgbClr val="FFF3CC"/>
+          </a:solidFill>
+          <a:ln>
+            <a:noFill/>
+          </a:ln>
+        </p:spPr>
+        <p:txBody>
+          <a:bodyPr rtlCol="0" anchor="ctr" wrap="square" lIns="182880" rIns="182880" tIns="0" bIns="0"/>
+          <a:lstStyle/>
+          <a:p>
+            <a:pPr algn="l"/>
             <a:r>
-              <a:rPr sz="1800" b="0">
+              <a:rPr sz="1700" b="0">
                 <a:solidFill>
                   <a:srgbClr val="062D3F"/>
                 </a:solidFill>
                 <a:latin typeface="Circe"/>
               </a:rPr>
-              <a:t> к 2030; неочищенных стоков вдвое меньше к 2036</a:t>
+              <a:t>Неочищенных стоков вдвое меньше</a:t>
             </a:r>
           </a:p>
         </p:txBody>
       </p:sp>
       <p:sp>
         <p:nvSpPr>
-          <p:cNvPr id="224" name="Роль села"/>
+          <p:cNvPr id="231" name="Роль села"/>
           <p:cNvSpPr/>
           <p:nvPr/>
         </p:nvSpPr>
         <p:spPr>
           <a:xfrm>
-            <a:off x="12134088" y="7406640"/>
-            <a:ext cx="5806440" cy="841248"/>
+            <a:off x="12829032" y="7406640"/>
+            <a:ext cx="5111495" cy="841248"/>
           </a:xfrm>
           <a:prstGeom prst="roundRect">
             <a:avLst>
@@ -7399,7 +7616,7 @@
           <a:p>
             <a:pPr algn="l"/>
             <a:r>
-              <a:rPr sz="1800" b="0">
+              <a:rPr sz="1700" b="0">
                 <a:solidFill>
                   <a:srgbClr val="062D3F"/>
                 </a:solidFill>
@@ -7412,7 +7629,7 @@
       </p:sp>
       <p:sp>
         <p:nvSpPr>
-          <p:cNvPr id="225" name="Вывод"/>
+          <p:cNvPr id="232" name="Вывод"/>
           <p:cNvSpPr/>
           <p:nvPr/>
         </p:nvSpPr>

</xml_diff>

<commit_message>
Fit takeaway bar on one line, render preview with Circe Bold
Co-Authored-By: Claude Sonnet 5.5 <noreply@anthropic.com>
Claude-Session: https://claude.ai/code/session_01PfagTkBBfn3ShTm5bX9M45
</commit_message>
<xml_diff>
--- a/slide_natsproekty.pptx
+++ b/slide_natsproekty.pptx
@@ -7656,7 +7656,7 @@
           <a:p>
             <a:pPr algn="l"/>
             <a:r>
-              <a:rPr sz="1900" b="1">
+              <a:rPr sz="1800" b="1">
                 <a:solidFill>
                   <a:srgbClr val="FFCC00"/>
                 </a:solidFill>
@@ -7665,7 +7665,7 @@
               <a:t>Прямо про село — только программа «Комплексное развитие сельских территорий»: </a:t>
             </a:r>
             <a:r>
-              <a:rPr sz="1900" b="0">
+              <a:rPr sz="1800" b="0">
                 <a:solidFill>
                   <a:srgbClr val="FFFFFF"/>
                 </a:solidFill>

</xml_diff>